<commit_message>
Final pass: rebuild all days with final renderer, rebalance quiz answer positions, generate README
Co-Authored-By: Claude Opus 5.5 <noreply@anthropic.com>
Claude-Session: https://claude.ai/code/session_019BWGGVhGSq3sUoebs4nKkF
</commit_message>
<xml_diff>
--- a/Day02-Python-Basics-Functions-and-Files/Day02_Deck_Python_Basics_Functions_and_Files.pptx
+++ b/Day02-Python-Basics-Functions-and-Files/Day02_Deck_Python_Basics_Functions_and_Files.pptx
@@ -3759,7 +3759,7 @@
           <a:noFill/>
         </p:spPr>
         <p:txBody>
-          <a:bodyPr wrap="square" lIns="0" rIns="0" tIns="0" bIns="0" anchor="t">
+          <a:bodyPr wrap="none" lIns="0" rIns="0" tIns="0" bIns="0" anchor="t">
             <a:spAutoFit/>
           </a:bodyPr>
           <a:lstStyle/>
@@ -5809,13 +5809,13 @@
           <a:noFill/>
         </p:spPr>
         <p:txBody>
-          <a:bodyPr wrap="square" lIns="0" rIns="0" tIns="0" bIns="0" anchor="t">
-            <a:spAutoFit/>
-          </a:bodyPr>
-          <a:lstStyle/>
-          <a:p>
-            <a:r>
-              <a:rPr sz="1243" b="0" i="0">
+          <a:bodyPr wrap="none" lIns="0" rIns="0" tIns="0" bIns="0" anchor="t">
+            <a:spAutoFit/>
+          </a:bodyPr>
+          <a:lstStyle/>
+          <a:p>
+            <a:r>
+              <a:rPr sz="1094" b="0" i="0">
                 <a:solidFill>
                   <a:srgbClr val="EAF7F5"/>
                 </a:solidFill>
@@ -5826,7 +5826,7 @@
           </a:p>
           <a:p>
             <a:r>
-              <a:rPr sz="1243" b="0" i="0">
+              <a:rPr sz="1094" b="0" i="0">
                 <a:solidFill>
                   <a:srgbClr val="EAF7F5"/>
                 </a:solidFill>
@@ -5837,7 +5837,7 @@
           </a:p>
           <a:p>
             <a:r>
-              <a:rPr sz="1243" b="0" i="0">
+              <a:rPr sz="1094" b="0" i="0">
                 <a:solidFill>
                   <a:srgbClr val="EAF7F5"/>
                 </a:solidFill>
@@ -5848,7 +5848,7 @@
           </a:p>
           <a:p>
             <a:r>
-              <a:rPr sz="1243" b="0" i="0">
+              <a:rPr sz="1094" b="0" i="0">
                 <a:solidFill>
                   <a:srgbClr val="EAF7F5"/>
                 </a:solidFill>
@@ -5859,7 +5859,7 @@
           </a:p>
           <a:p>
             <a:r>
-              <a:rPr sz="1243" b="0" i="0">
+              <a:rPr sz="1094" b="0" i="0">
                 <a:solidFill>
                   <a:srgbClr val="EAF7F5"/>
                 </a:solidFill>
@@ -5870,7 +5870,7 @@
           </a:p>
           <a:p>
             <a:r>
-              <a:rPr sz="1243" b="0" i="0">
+              <a:rPr sz="1094" b="0" i="0">
                 <a:solidFill>
                   <a:srgbClr val="EAF7F5"/>
                 </a:solidFill>
@@ -5881,7 +5881,7 @@
           </a:p>
           <a:p>
             <a:r>
-              <a:rPr sz="1243" b="0" i="0">
+              <a:rPr sz="1094" b="0" i="0">
                 <a:solidFill>
                   <a:srgbClr val="EAF7F5"/>
                 </a:solidFill>
@@ -5892,7 +5892,7 @@
           </a:p>
           <a:p>
             <a:r>
-              <a:rPr sz="1243" b="0" i="0">
+              <a:rPr sz="1094" b="0" i="0">
                 <a:solidFill>
                   <a:srgbClr val="EAF7F5"/>
                 </a:solidFill>
@@ -5903,7 +5903,7 @@
           </a:p>
           <a:p>
             <a:r>
-              <a:rPr sz="1243" b="0" i="0">
+              <a:rPr sz="1094" b="0" i="0">
                 <a:solidFill>
                   <a:srgbClr val="EAF7F5"/>
                 </a:solidFill>
@@ -5914,7 +5914,7 @@
           </a:p>
           <a:p>
             <a:r>
-              <a:rPr sz="1243" b="0" i="0">
+              <a:rPr sz="1094" b="0" i="0">
                 <a:solidFill>
                   <a:srgbClr val="EAF7F5"/>
                 </a:solidFill>
@@ -5925,7 +5925,7 @@
           </a:p>
           <a:p>
             <a:r>
-              <a:rPr sz="1243" b="0" i="0">
+              <a:rPr sz="1094" b="0" i="0">
                 <a:solidFill>
                   <a:srgbClr val="EAF7F5"/>
                 </a:solidFill>
@@ -9633,13 +9633,13 @@
           <a:noFill/>
         </p:spPr>
         <p:txBody>
-          <a:bodyPr wrap="square" lIns="0" rIns="0" tIns="0" bIns="0" anchor="t">
-            <a:spAutoFit/>
-          </a:bodyPr>
-          <a:lstStyle/>
-          <a:p>
-            <a:r>
-              <a:rPr sz="1400" b="0" i="0">
+          <a:bodyPr wrap="none" lIns="0" rIns="0" tIns="0" bIns="0" anchor="t">
+            <a:spAutoFit/>
+          </a:bodyPr>
+          <a:lstStyle/>
+          <a:p>
+            <a:r>
+              <a:rPr sz="1282" b="0" i="0">
                 <a:solidFill>
                   <a:srgbClr val="EAF7F5"/>
                 </a:solidFill>
@@ -9650,7 +9650,7 @@
           </a:p>
           <a:p>
             <a:r>
-              <a:rPr sz="1400" b="0" i="0">
+              <a:rPr sz="1282" b="0" i="0">
                 <a:solidFill>
                   <a:srgbClr val="EAF7F5"/>
                 </a:solidFill>
@@ -9661,7 +9661,7 @@
           </a:p>
           <a:p>
             <a:r>
-              <a:rPr sz="1400" b="0" i="0">
+              <a:rPr sz="1282" b="0" i="0">
                 <a:solidFill>
                   <a:srgbClr val="EAF7F5"/>
                 </a:solidFill>
@@ -9672,7 +9672,7 @@
           </a:p>
           <a:p>
             <a:r>
-              <a:rPr sz="1400" b="0" i="0">
+              <a:rPr sz="1282" b="0" i="0">
                 <a:solidFill>
                   <a:srgbClr val="EAF7F5"/>
                 </a:solidFill>
@@ -9683,7 +9683,7 @@
           </a:p>
           <a:p>
             <a:r>
-              <a:rPr sz="1400" b="0" i="0">
+              <a:rPr sz="1282" b="0" i="0">
                 <a:solidFill>
                   <a:srgbClr val="EAF7F5"/>
                 </a:solidFill>
@@ -9694,7 +9694,7 @@
           </a:p>
           <a:p>
             <a:r>
-              <a:rPr sz="1400" b="0" i="0">
+              <a:rPr sz="1282" b="0" i="0">
                 <a:solidFill>
                   <a:srgbClr val="EAF7F5"/>
                 </a:solidFill>
@@ -9705,7 +9705,7 @@
           </a:p>
           <a:p>
             <a:r>
-              <a:rPr sz="1400" b="0" i="0">
+              <a:rPr sz="1282" b="0" i="0">
                 <a:solidFill>
                   <a:srgbClr val="EAF7F5"/>
                 </a:solidFill>
@@ -9716,7 +9716,7 @@
           </a:p>
           <a:p>
             <a:r>
-              <a:rPr sz="1400" b="0" i="0">
+              <a:rPr sz="1282" b="0" i="0">
                 <a:solidFill>
                   <a:srgbClr val="EAF7F5"/>
                 </a:solidFill>
@@ -9727,7 +9727,7 @@
           </a:p>
           <a:p>
             <a:r>
-              <a:rPr sz="1400" b="0" i="0">
+              <a:rPr sz="1282" b="0" i="0">
                 <a:solidFill>
                   <a:srgbClr val="EAF7F5"/>
                 </a:solidFill>
@@ -9738,7 +9738,7 @@
           </a:p>
           <a:p>
             <a:r>
-              <a:rPr sz="1400" b="0" i="0">
+              <a:rPr sz="1282" b="0" i="0">
                 <a:solidFill>
                   <a:srgbClr val="EAF7F5"/>
                 </a:solidFill>
@@ -10469,13 +10469,13 @@
           <a:noFill/>
         </p:spPr>
         <p:txBody>
-          <a:bodyPr wrap="square" lIns="0" rIns="0" tIns="0" bIns="0" anchor="t">
-            <a:spAutoFit/>
-          </a:bodyPr>
-          <a:lstStyle/>
-          <a:p>
-            <a:r>
-              <a:rPr sz="1307" b="0" i="0">
+          <a:bodyPr wrap="none" lIns="0" rIns="0" tIns="0" bIns="0" anchor="t">
+            <a:spAutoFit/>
+          </a:bodyPr>
+          <a:lstStyle/>
+          <a:p>
+            <a:r>
+              <a:rPr sz="1150" b="0" i="0">
                 <a:solidFill>
                   <a:srgbClr val="EAF7F5"/>
                 </a:solidFill>
@@ -10486,7 +10486,7 @@
           </a:p>
           <a:p>
             <a:r>
-              <a:rPr sz="1307" b="0" i="0">
+              <a:rPr sz="1150" b="0" i="0">
                 <a:solidFill>
                   <a:srgbClr val="EAF7F5"/>
                 </a:solidFill>
@@ -10497,7 +10497,7 @@
           </a:p>
           <a:p>
             <a:r>
-              <a:rPr sz="1307" b="0" i="0">
+              <a:rPr sz="1150" b="0" i="0">
                 <a:solidFill>
                   <a:srgbClr val="EAF7F5"/>
                 </a:solidFill>
@@ -10508,7 +10508,7 @@
           </a:p>
           <a:p>
             <a:r>
-              <a:rPr sz="1307" b="0" i="0">
+              <a:rPr sz="1150" b="0" i="0">
                 <a:solidFill>
                   <a:srgbClr val="EAF7F5"/>
                 </a:solidFill>
@@ -10519,7 +10519,7 @@
           </a:p>
           <a:p>
             <a:r>
-              <a:rPr sz="1307" b="0" i="0">
+              <a:rPr sz="1150" b="0" i="0">
                 <a:solidFill>
                   <a:srgbClr val="EAF7F5"/>
                 </a:solidFill>
@@ -10530,7 +10530,7 @@
           </a:p>
           <a:p>
             <a:r>
-              <a:rPr sz="1307" b="0" i="0">
+              <a:rPr sz="1150" b="0" i="0">
                 <a:solidFill>
                   <a:srgbClr val="EAF7F5"/>
                 </a:solidFill>
@@ -10541,7 +10541,7 @@
           </a:p>
           <a:p>
             <a:r>
-              <a:rPr sz="1307" b="0" i="0">
+              <a:rPr sz="1150" b="0" i="0">
                 <a:solidFill>
                   <a:srgbClr val="EAF7F5"/>
                 </a:solidFill>
@@ -10864,13 +10864,13 @@
           <a:noFill/>
         </p:spPr>
         <p:txBody>
-          <a:bodyPr wrap="square" lIns="0" rIns="0" tIns="0" bIns="0" anchor="t">
-            <a:spAutoFit/>
-          </a:bodyPr>
-          <a:lstStyle/>
-          <a:p>
-            <a:r>
-              <a:rPr sz="1275" b="0" i="0">
+          <a:bodyPr wrap="none" lIns="0" rIns="0" tIns="0" bIns="0" anchor="t">
+            <a:spAutoFit/>
+          </a:bodyPr>
+          <a:lstStyle/>
+          <a:p>
+            <a:r>
+              <a:rPr sz="1122" b="0" i="0">
                 <a:solidFill>
                   <a:srgbClr val="EAF7F5"/>
                 </a:solidFill>
@@ -10881,7 +10881,7 @@
           </a:p>
           <a:p>
             <a:r>
-              <a:rPr sz="1275" b="0" i="0">
+              <a:rPr sz="1122" b="0" i="0">
                 <a:solidFill>
                   <a:srgbClr val="EAF7F5"/>
                 </a:solidFill>
@@ -10892,7 +10892,7 @@
           </a:p>
           <a:p>
             <a:r>
-              <a:rPr sz="1275" b="0" i="0">
+              <a:rPr sz="1122" b="0" i="0">
                 <a:solidFill>
                   <a:srgbClr val="EAF7F5"/>
                 </a:solidFill>
@@ -10903,7 +10903,7 @@
           </a:p>
           <a:p>
             <a:r>
-              <a:rPr sz="1275" b="0" i="0">
+              <a:rPr sz="1122" b="0" i="0">
                 <a:solidFill>
                   <a:srgbClr val="EAF7F5"/>
                 </a:solidFill>
@@ -10914,7 +10914,7 @@
           </a:p>
           <a:p>
             <a:r>
-              <a:rPr sz="1275" b="0" i="0">
+              <a:rPr sz="1122" b="0" i="0">
                 <a:solidFill>
                   <a:srgbClr val="EAF7F5"/>
                 </a:solidFill>
@@ -10925,7 +10925,7 @@
           </a:p>
           <a:p>
             <a:r>
-              <a:rPr sz="1275" b="0" i="0">
+              <a:rPr sz="1122" b="0" i="0">
                 <a:solidFill>
                   <a:srgbClr val="EAF7F5"/>
                 </a:solidFill>
@@ -10936,7 +10936,7 @@
           </a:p>
           <a:p>
             <a:r>
-              <a:rPr sz="1275" b="0" i="0">
+              <a:rPr sz="1122" b="0" i="0">
                 <a:solidFill>
                   <a:srgbClr val="EAF7F5"/>
                 </a:solidFill>
@@ -10947,7 +10947,7 @@
           </a:p>
           <a:p>
             <a:r>
-              <a:rPr sz="1275" b="0" i="0">
+              <a:rPr sz="1122" b="0" i="0">
                 <a:solidFill>
                   <a:srgbClr val="EAF7F5"/>
                 </a:solidFill>
@@ -10958,7 +10958,7 @@
           </a:p>
           <a:p>
             <a:r>
-              <a:rPr sz="1275" b="0" i="0">
+              <a:rPr sz="1122" b="0" i="0">
                 <a:solidFill>
                   <a:srgbClr val="EAF7F5"/>
                 </a:solidFill>
@@ -12204,13 +12204,13 @@
           <a:noFill/>
         </p:spPr>
         <p:txBody>
-          <a:bodyPr wrap="square" lIns="0" rIns="0" tIns="0" bIns="0" anchor="t">
-            <a:spAutoFit/>
-          </a:bodyPr>
-          <a:lstStyle/>
-          <a:p>
-            <a:r>
-              <a:rPr sz="1133" b="0" i="0">
+          <a:bodyPr wrap="none" lIns="0" rIns="0" tIns="0" bIns="0" anchor="t">
+            <a:spAutoFit/>
+          </a:bodyPr>
+          <a:lstStyle/>
+          <a:p>
+            <a:r>
+              <a:rPr sz="997" b="0" i="0">
                 <a:solidFill>
                   <a:srgbClr val="EAF7F5"/>
                 </a:solidFill>
@@ -12221,7 +12221,7 @@
           </a:p>
           <a:p>
             <a:r>
-              <a:rPr sz="1133" b="0" i="0">
+              <a:rPr sz="997" b="0" i="0">
                 <a:solidFill>
                   <a:srgbClr val="EAF7F5"/>
                 </a:solidFill>
@@ -12232,7 +12232,7 @@
           </a:p>
           <a:p>
             <a:r>
-              <a:rPr sz="1133" b="0" i="0">
+              <a:rPr sz="997" b="0" i="0">
                 <a:solidFill>
                   <a:srgbClr val="EAF7F5"/>
                 </a:solidFill>
@@ -12243,7 +12243,7 @@
           </a:p>
           <a:p>
             <a:r>
-              <a:rPr sz="1133" b="0" i="0">
+              <a:rPr sz="997" b="0" i="0">
                 <a:solidFill>
                   <a:srgbClr val="EAF7F5"/>
                 </a:solidFill>
@@ -12254,7 +12254,7 @@
           </a:p>
           <a:p>
             <a:r>
-              <a:rPr sz="1133" b="0" i="0">
+              <a:rPr sz="997" b="0" i="0">
                 <a:solidFill>
                   <a:srgbClr val="EAF7F5"/>
                 </a:solidFill>
@@ -12265,7 +12265,7 @@
           </a:p>
           <a:p>
             <a:r>
-              <a:rPr sz="1133" b="0" i="0">
+              <a:rPr sz="997" b="0" i="0">
                 <a:solidFill>
                   <a:srgbClr val="EAF7F5"/>
                 </a:solidFill>
@@ -12276,7 +12276,7 @@
           </a:p>
           <a:p>
             <a:r>
-              <a:rPr sz="1133" b="0" i="0">
+              <a:rPr sz="997" b="0" i="0">
                 <a:solidFill>
                   <a:srgbClr val="EAF7F5"/>
                 </a:solidFill>
@@ -12287,7 +12287,7 @@
           </a:p>
           <a:p>
             <a:r>
-              <a:rPr sz="1133" b="0" i="0">
+              <a:rPr sz="997" b="0" i="0">
                 <a:solidFill>
                   <a:srgbClr val="EAF7F5"/>
                 </a:solidFill>
@@ -12298,7 +12298,7 @@
           </a:p>
           <a:p>
             <a:r>
-              <a:rPr sz="1133" b="0" i="0">
+              <a:rPr sz="997" b="0" i="0">
                 <a:solidFill>
                   <a:srgbClr val="EAF7F5"/>
                 </a:solidFill>
@@ -12309,7 +12309,7 @@
           </a:p>
           <a:p>
             <a:r>
-              <a:rPr sz="1133" b="0" i="0">
+              <a:rPr sz="997" b="0" i="0">
                 <a:solidFill>
                   <a:srgbClr val="EAF7F5"/>
                 </a:solidFill>
@@ -12320,7 +12320,7 @@
           </a:p>
           <a:p>
             <a:r>
-              <a:rPr sz="1133" b="0" i="0">
+              <a:rPr sz="997" b="0" i="0">
                 <a:solidFill>
                   <a:srgbClr val="EAF7F5"/>
                 </a:solidFill>
@@ -12608,13 +12608,13 @@
           <a:noFill/>
         </p:spPr>
         <p:txBody>
-          <a:bodyPr wrap="square" lIns="0" rIns="0" tIns="0" bIns="0" anchor="t">
-            <a:spAutoFit/>
-          </a:bodyPr>
-          <a:lstStyle/>
-          <a:p>
-            <a:r>
-              <a:rPr sz="1275" b="0" i="0">
+          <a:bodyPr wrap="none" lIns="0" rIns="0" tIns="0" bIns="0" anchor="t">
+            <a:spAutoFit/>
+          </a:bodyPr>
+          <a:lstStyle/>
+          <a:p>
+            <a:r>
+              <a:rPr sz="1122" b="0" i="0">
                 <a:solidFill>
                   <a:srgbClr val="EAF7F5"/>
                 </a:solidFill>
@@ -12625,7 +12625,7 @@
           </a:p>
           <a:p>
             <a:r>
-              <a:rPr sz="1275" b="0" i="0">
+              <a:rPr sz="1122" b="0" i="0">
                 <a:solidFill>
                   <a:srgbClr val="EAF7F5"/>
                 </a:solidFill>
@@ -12636,7 +12636,7 @@
           </a:p>
           <a:p>
             <a:r>
-              <a:rPr sz="1275" b="0" i="0">
+              <a:rPr sz="1122" b="0" i="0">
                 <a:solidFill>
                   <a:srgbClr val="EAF7F5"/>
                 </a:solidFill>
@@ -12647,7 +12647,7 @@
           </a:p>
           <a:p>
             <a:r>
-              <a:rPr sz="1275" b="0" i="0">
+              <a:rPr sz="1122" b="0" i="0">
                 <a:solidFill>
                   <a:srgbClr val="EAF7F5"/>
                 </a:solidFill>
@@ -12658,7 +12658,7 @@
           </a:p>
           <a:p>
             <a:r>
-              <a:rPr sz="1275" b="0" i="0">
+              <a:rPr sz="1122" b="0" i="0">
                 <a:solidFill>
                   <a:srgbClr val="EAF7F5"/>
                 </a:solidFill>
@@ -12669,7 +12669,7 @@
           </a:p>
           <a:p>
             <a:r>
-              <a:rPr sz="1275" b="0" i="0">
+              <a:rPr sz="1122" b="0" i="0">
                 <a:solidFill>
                   <a:srgbClr val="EAF7F5"/>
                 </a:solidFill>
@@ -12680,7 +12680,7 @@
           </a:p>
           <a:p>
             <a:r>
-              <a:rPr sz="1275" b="0" i="0">
+              <a:rPr sz="1122" b="0" i="0">
                 <a:solidFill>
                   <a:srgbClr val="EAF7F5"/>
                 </a:solidFill>
@@ -12691,7 +12691,7 @@
           </a:p>
           <a:p>
             <a:r>
-              <a:rPr sz="1275" b="0" i="0">
+              <a:rPr sz="1122" b="0" i="0">
                 <a:solidFill>
                   <a:srgbClr val="EAF7F5"/>
                 </a:solidFill>
@@ -12702,7 +12702,7 @@
           </a:p>
           <a:p>
             <a:r>
-              <a:rPr sz="1275" b="0" i="0">
+              <a:rPr sz="1122" b="0" i="0">
                 <a:solidFill>
                   <a:srgbClr val="EAF7F5"/>
                 </a:solidFill>
@@ -12713,7 +12713,7 @@
           </a:p>
           <a:p>
             <a:r>
-              <a:rPr sz="1275" b="0" i="0">
+              <a:rPr sz="1122" b="0" i="0">
                 <a:solidFill>
                   <a:srgbClr val="EAF7F5"/>
                 </a:solidFill>
@@ -15317,13 +15317,13 @@
           <a:noFill/>
         </p:spPr>
         <p:txBody>
-          <a:bodyPr wrap="square" lIns="0" rIns="0" tIns="0" bIns="0" anchor="t">
-            <a:spAutoFit/>
-          </a:bodyPr>
-          <a:lstStyle/>
-          <a:p>
-            <a:r>
-              <a:rPr sz="1275" b="0" i="0">
+          <a:bodyPr wrap="none" lIns="0" rIns="0" tIns="0" bIns="0" anchor="t">
+            <a:spAutoFit/>
+          </a:bodyPr>
+          <a:lstStyle/>
+          <a:p>
+            <a:r>
+              <a:rPr sz="1122" b="0" i="0">
                 <a:solidFill>
                   <a:srgbClr val="EAF7F5"/>
                 </a:solidFill>
@@ -15334,7 +15334,7 @@
           </a:p>
           <a:p>
             <a:r>
-              <a:rPr sz="1275" b="0" i="0">
+              <a:rPr sz="1122" b="0" i="0">
                 <a:solidFill>
                   <a:srgbClr val="EAF7F5"/>
                 </a:solidFill>
@@ -15345,7 +15345,7 @@
           </a:p>
           <a:p>
             <a:r>
-              <a:rPr sz="1275" b="0" i="0">
+              <a:rPr sz="1122" b="0" i="0">
                 <a:solidFill>
                   <a:srgbClr val="EAF7F5"/>
                 </a:solidFill>
@@ -15356,7 +15356,7 @@
           </a:p>
           <a:p>
             <a:r>
-              <a:rPr sz="1275" b="0" i="0">
+              <a:rPr sz="1122" b="0" i="0">
                 <a:solidFill>
                   <a:srgbClr val="EAF7F5"/>
                 </a:solidFill>
@@ -15367,7 +15367,7 @@
           </a:p>
           <a:p>
             <a:r>
-              <a:rPr sz="1275" b="0" i="0">
+              <a:rPr sz="1122" b="0" i="0">
                 <a:solidFill>
                   <a:srgbClr val="EAF7F5"/>
                 </a:solidFill>
@@ -15378,7 +15378,7 @@
           </a:p>
           <a:p>
             <a:r>
-              <a:rPr sz="1275" b="0" i="0">
+              <a:rPr sz="1122" b="0" i="0">
                 <a:solidFill>
                   <a:srgbClr val="EAF7F5"/>
                 </a:solidFill>
@@ -15389,7 +15389,7 @@
           </a:p>
           <a:p>
             <a:r>
-              <a:rPr sz="1275" b="0" i="0">
+              <a:rPr sz="1122" b="0" i="0">
                 <a:solidFill>
                   <a:srgbClr val="EAF7F5"/>
                 </a:solidFill>
@@ -15400,7 +15400,7 @@
           </a:p>
           <a:p>
             <a:r>
-              <a:rPr sz="1275" b="0" i="0">
+              <a:rPr sz="1122" b="0" i="0">
                 <a:solidFill>
                   <a:srgbClr val="EAF7F5"/>
                 </a:solidFill>
@@ -15411,7 +15411,7 @@
           </a:p>
           <a:p>
             <a:r>
-              <a:rPr sz="1275" b="0" i="0">
+              <a:rPr sz="1122" b="0" i="0">
                 <a:solidFill>
                   <a:srgbClr val="EAF7F5"/>
                 </a:solidFill>
@@ -19237,13 +19237,13 @@
           <a:noFill/>
         </p:spPr>
         <p:txBody>
-          <a:bodyPr wrap="square" lIns="0" rIns="0" tIns="0" bIns="0" anchor="t">
-            <a:spAutoFit/>
-          </a:bodyPr>
-          <a:lstStyle/>
-          <a:p>
-            <a:r>
-              <a:rPr sz="980" b="0" i="0">
+          <a:bodyPr wrap="none" lIns="0" rIns="0" tIns="0" bIns="0" anchor="t">
+            <a:spAutoFit/>
+          </a:bodyPr>
+          <a:lstStyle/>
+          <a:p>
+            <a:r>
+              <a:rPr sz="863" b="0" i="0">
                 <a:solidFill>
                   <a:srgbClr val="EAF7F5"/>
                 </a:solidFill>
@@ -19254,7 +19254,7 @@
           </a:p>
           <a:p>
             <a:r>
-              <a:rPr sz="980" b="0" i="0">
+              <a:rPr sz="863" b="0" i="0">
                 <a:solidFill>
                   <a:srgbClr val="EAF7F5"/>
                 </a:solidFill>
@@ -19265,7 +19265,7 @@
           </a:p>
           <a:p>
             <a:r>
-              <a:rPr sz="980" b="0" i="0">
+              <a:rPr sz="863" b="0" i="0">
                 <a:solidFill>
                   <a:srgbClr val="EAF7F5"/>
                 </a:solidFill>
@@ -19276,7 +19276,7 @@
           </a:p>
           <a:p>
             <a:r>
-              <a:rPr sz="980" b="0" i="0">
+              <a:rPr sz="863" b="0" i="0">
                 <a:solidFill>
                   <a:srgbClr val="EAF7F5"/>
                 </a:solidFill>
@@ -19287,7 +19287,7 @@
           </a:p>
           <a:p>
             <a:r>
-              <a:rPr sz="980" b="0" i="0">
+              <a:rPr sz="863" b="0" i="0">
                 <a:solidFill>
                   <a:srgbClr val="EAF7F5"/>
                 </a:solidFill>
@@ -19298,7 +19298,7 @@
           </a:p>
           <a:p>
             <a:r>
-              <a:rPr sz="980" b="0" i="0">
+              <a:rPr sz="863" b="0" i="0">
                 <a:solidFill>
                   <a:srgbClr val="EAF7F5"/>
                 </a:solidFill>
@@ -19309,7 +19309,7 @@
           </a:p>
           <a:p>
             <a:r>
-              <a:rPr sz="980" b="0" i="0">
+              <a:rPr sz="863" b="0" i="0">
                 <a:solidFill>
                   <a:srgbClr val="EAF7F5"/>
                 </a:solidFill>
@@ -19320,7 +19320,7 @@
           </a:p>
           <a:p>
             <a:r>
-              <a:rPr sz="980" b="0" i="0">
+              <a:rPr sz="863" b="0" i="0">
                 <a:solidFill>
                   <a:srgbClr val="EAF7F5"/>
                 </a:solidFill>
@@ -19331,7 +19331,7 @@
           </a:p>
           <a:p>
             <a:r>
-              <a:rPr sz="980" b="0" i="0">
+              <a:rPr sz="863" b="0" i="0">
                 <a:solidFill>
                   <a:srgbClr val="EAF7F5"/>
                 </a:solidFill>
@@ -19342,7 +19342,7 @@
           </a:p>
           <a:p>
             <a:r>
-              <a:rPr sz="980" b="0" i="0">
+              <a:rPr sz="863" b="0" i="0">
                 <a:solidFill>
                   <a:srgbClr val="EAF7F5"/>
                 </a:solidFill>
@@ -19353,7 +19353,7 @@
           </a:p>
           <a:p>
             <a:r>
-              <a:rPr sz="980" b="0" i="0">
+              <a:rPr sz="863" b="0" i="0">
                 <a:solidFill>
                   <a:srgbClr val="EAF7F5"/>
                 </a:solidFill>
@@ -19364,7 +19364,7 @@
           </a:p>
           <a:p>
             <a:r>
-              <a:rPr sz="980" b="0" i="0">
+              <a:rPr sz="863" b="0" i="0">
                 <a:solidFill>
                   <a:srgbClr val="EAF7F5"/>
                 </a:solidFill>

</xml_diff>